<commit_message>
vault backup: 2026-08-30 09:00:33
</commit_message>
<xml_diff>
--- a/説教準備/20260830マルコ3-7-19 「十字架への道」.pptx
+++ b/説教準備/20260830マルコ3-7-19 「十字架への道」.pptx
@@ -36,6 +36,7 @@
     <p:sldId id="318" r:id="rId1029"/>
     <p:sldId id="319" r:id="rId1030"/>
     <p:sldId id="320" r:id="rId1031"/>
+    <p:sldId id="321" r:id="rId1032"/>
   </p:sldIdLst>
   <p:sldSz cx="12192000" cy="6858000"/>
   <p:notesSz cx="6858000" cy="9144000"/>
@@ -962,50 +963,23 @@
                 <a:ea typeface="Meiryo UI" panose="020B0604030504040204" pitchFamily="34" charset="-128"/>
                 <a:cs typeface="ＭＳ Ｐゴシック" panose="020B0600070205080204" pitchFamily="34" charset="-128"/>
               </a:rPr>
-              <a:t>Mark 5:27</a:t>
-            </a:r>
-            <a:r>
-              <a:rPr lang="en-US" altLang="ja-JP" dirty="0">
-                <a:latin typeface="小塚明朝 Pro L"/>
-                <a:ea typeface="Meiryo UI" panose="020B0604030504040204" pitchFamily="34" charset="-128"/>
-                <a:cs typeface="ＭＳ Ｐゴシック" panose="020B0600070205080204" pitchFamily="34" charset="-128"/>
-              </a:rPr>
-              <a:t xml:space="preserve">  </a:t>
-            </a:r>
-            <a:r>
-              <a:rPr lang="ja-JP" altLang="ja-JP">
-                <a:latin typeface="小塚明朝 Pro L"/>
-                <a:ea typeface="Meiryo UI" panose="020B0604030504040204" pitchFamily="34" charset="-128"/>
-                <a:cs typeface="ＭＳ Ｐゴシック" panose="020B0600070205080204" pitchFamily="34" charset="-128"/>
-              </a:rPr>
-              <a:t>彼女はイエスのことを聞き、群衆とともにやって来て、うしろからイエスの衣に触れた。</a:t>
-            </a:r>
-          </a:p>
-          <a:p>
-            <a:pPr marL="152400" marR="152400"/>
-            <a:r>
-              <a:rPr lang="en-US" altLang="ja-JP" dirty="0">
-                <a:latin typeface="小塚明朝 Pro L"/>
-                <a:ea typeface="Meiryo UI" panose="020B0604030504040204" pitchFamily="34" charset="-128"/>
-                <a:cs typeface="ＭＳ Ｐゴシック" panose="020B0600070205080204" pitchFamily="34" charset="-128"/>
-              </a:rPr>
-              <a:t>Mark 5:28</a:t>
-            </a:r>
-            <a:r>
-              <a:rPr lang="en-US" altLang="ja-JP" dirty="0">
-                <a:latin typeface="小塚明朝 Pro L"/>
-                <a:ea typeface="Meiryo UI" panose="020B0604030504040204" pitchFamily="34" charset="-128"/>
-                <a:cs typeface="ＭＳ Ｐゴシック" panose="020B0600070205080204" pitchFamily="34" charset="-128"/>
-              </a:rPr>
-              <a:t xml:space="preserve">  </a:t>
-            </a:r>
-            <a:r>
-              <a:rPr lang="ja-JP" altLang="ja-JP">
-                <a:latin typeface="小塚明朝 Pro L"/>
-                <a:ea typeface="Meiryo UI" panose="020B0604030504040204" pitchFamily="34" charset="-128"/>
-                <a:cs typeface="ＭＳ Ｐゴシック" panose="020B0600070205080204" pitchFamily="34" charset="-128"/>
-              </a:rPr>
-              <a:t>「あの方の衣にでも触れれば、私は救われる」と思っていたからである。</a:t>
+              <a:t>Mark 3:5</a:t>
+            </a:r>
+            <a:r>
+              <a:rPr lang="en-US" altLang="ja-JP" dirty="0">
+                <a:latin typeface="小塚明朝 Pro L"/>
+                <a:ea typeface="Meiryo UI" panose="020B0604030504040204" pitchFamily="34" charset="-128"/>
+                <a:cs typeface="ＭＳ Ｐゴシック" panose="020B0600070205080204" pitchFamily="34" charset="-128"/>
+              </a:rPr>
+              <a:t xml:space="preserve">  </a:t>
+            </a:r>
+            <a:r>
+              <a:rPr lang="ja-JP" altLang="ja-JP">
+                <a:latin typeface="小塚明朝 Pro L"/>
+                <a:ea typeface="Meiryo UI" panose="020B0604030504040204" pitchFamily="34" charset="-128"/>
+                <a:cs typeface="ＭＳ Ｐゴシック" panose="020B0600070205080204" pitchFamily="34" charset="-128"/>
+              </a:rPr>
+              <a:t>イエスは怒って彼らを見回し、その心の頑なさを嘆き悲しみながら、その人に「手を伸ばしなさい」と言われた。彼が手を伸ばすと、手は元どおりになった。</a:t>
             </a:r>
           </a:p>
           <a:p>
@@ -1077,23 +1051,50 @@
                 <a:ea typeface="Meiryo UI" panose="020B0604030504040204" pitchFamily="34" charset="-128"/>
                 <a:cs typeface="ＭＳ Ｐゴシック" panose="020B0600070205080204" pitchFamily="34" charset="-128"/>
               </a:rPr>
-              <a:t>Mark 5:34</a:t>
-            </a:r>
-            <a:r>
-              <a:rPr lang="en-US" altLang="ja-JP" dirty="0">
-                <a:latin typeface="小塚明朝 Pro L"/>
-                <a:ea typeface="Meiryo UI" panose="020B0604030504040204" pitchFamily="34" charset="-128"/>
-                <a:cs typeface="ＭＳ Ｐゴシック" panose="020B0600070205080204" pitchFamily="34" charset="-128"/>
-              </a:rPr>
-              <a:t xml:space="preserve">  </a:t>
-            </a:r>
-            <a:r>
-              <a:rPr lang="ja-JP" altLang="ja-JP">
-                <a:latin typeface="小塚明朝 Pro L"/>
-                <a:ea typeface="Meiryo UI" panose="020B0604030504040204" pitchFamily="34" charset="-128"/>
-                <a:cs typeface="ＭＳ Ｐゴシック" panose="020B0600070205080204" pitchFamily="34" charset="-128"/>
-              </a:rPr>
-              <a:t>イエスは彼女に言われた。「娘よ、あなたの信仰があなたを救ったのです。安心して行きなさい。苦しむことなく、健やかでいなさい。」</a:t>
+              <a:t>Mark 5:27</a:t>
+            </a:r>
+            <a:r>
+              <a:rPr lang="en-US" altLang="ja-JP" dirty="0">
+                <a:latin typeface="小塚明朝 Pro L"/>
+                <a:ea typeface="Meiryo UI" panose="020B0604030504040204" pitchFamily="34" charset="-128"/>
+                <a:cs typeface="ＭＳ Ｐゴシック" panose="020B0600070205080204" pitchFamily="34" charset="-128"/>
+              </a:rPr>
+              <a:t xml:space="preserve">  </a:t>
+            </a:r>
+            <a:r>
+              <a:rPr lang="ja-JP" altLang="ja-JP">
+                <a:latin typeface="小塚明朝 Pro L"/>
+                <a:ea typeface="Meiryo UI" panose="020B0604030504040204" pitchFamily="34" charset="-128"/>
+                <a:cs typeface="ＭＳ Ｐゴシック" panose="020B0600070205080204" pitchFamily="34" charset="-128"/>
+              </a:rPr>
+              <a:t>彼女はイエスのことを聞き、群衆とともにやって来て、うしろからイエスの衣に触れた。</a:t>
+            </a:r>
+          </a:p>
+          <a:p>
+            <a:pPr marL="152400" marR="152400"/>
+            <a:r>
+              <a:rPr lang="en-US" altLang="ja-JP" dirty="0">
+                <a:latin typeface="小塚明朝 Pro L"/>
+                <a:ea typeface="Meiryo UI" panose="020B0604030504040204" pitchFamily="34" charset="-128"/>
+                <a:cs typeface="ＭＳ Ｐゴシック" panose="020B0600070205080204" pitchFamily="34" charset="-128"/>
+              </a:rPr>
+              <a:t>Mark 5:28</a:t>
+            </a:r>
+            <a:r>
+              <a:rPr lang="en-US" altLang="ja-JP" dirty="0">
+                <a:latin typeface="小塚明朝 Pro L"/>
+                <a:ea typeface="Meiryo UI" panose="020B0604030504040204" pitchFamily="34" charset="-128"/>
+                <a:cs typeface="ＭＳ Ｐゴシック" panose="020B0600070205080204" pitchFamily="34" charset="-128"/>
+              </a:rPr>
+              <a:t xml:space="preserve">  </a:t>
+            </a:r>
+            <a:r>
+              <a:rPr lang="ja-JP" altLang="ja-JP">
+                <a:latin typeface="小塚明朝 Pro L"/>
+                <a:ea typeface="Meiryo UI" panose="020B0604030504040204" pitchFamily="34" charset="-128"/>
+                <a:cs typeface="ＭＳ Ｐゴシック" panose="020B0600070205080204" pitchFamily="34" charset="-128"/>
+              </a:rPr>
+              <a:t>「あの方の衣にでも触れれば、私は救われる」と思っていたからである。</a:t>
             </a:r>
           </a:p>
           <a:p>
@@ -1165,50 +1166,23 @@
                 <a:ea typeface="Meiryo UI" panose="020B0604030504040204" pitchFamily="34" charset="-128"/>
                 <a:cs typeface="ＭＳ Ｐゴシック" panose="020B0600070205080204" pitchFamily="34" charset="-128"/>
               </a:rPr>
-              <a:t>Mark 3:11</a:t>
-            </a:r>
-            <a:r>
-              <a:rPr lang="en-US" altLang="ja-JP" dirty="0">
-                <a:latin typeface="小塚明朝 Pro L"/>
-                <a:ea typeface="Meiryo UI" panose="020B0604030504040204" pitchFamily="34" charset="-128"/>
-                <a:cs typeface="ＭＳ Ｐゴシック" panose="020B0600070205080204" pitchFamily="34" charset="-128"/>
-              </a:rPr>
-              <a:t xml:space="preserve">  </a:t>
-            </a:r>
-            <a:r>
-              <a:rPr lang="ja-JP" altLang="ja-JP">
-                <a:latin typeface="小塚明朝 Pro L"/>
-                <a:ea typeface="Meiryo UI" panose="020B0604030504040204" pitchFamily="34" charset="-128"/>
-                <a:cs typeface="ＭＳ Ｐゴシック" panose="020B0600070205080204" pitchFamily="34" charset="-128"/>
-              </a:rPr>
-              <a:t>汚れた霊どもは、イエスを見るたびに御前にひれ伏して「あなたは神の子です」と叫んだ。</a:t>
-            </a:r>
-          </a:p>
-          <a:p>
-            <a:pPr marL="152400" marR="152400"/>
-            <a:r>
-              <a:rPr lang="en-US" altLang="ja-JP" dirty="0">
-                <a:latin typeface="小塚明朝 Pro L"/>
-                <a:ea typeface="Meiryo UI" panose="020B0604030504040204" pitchFamily="34" charset="-128"/>
-                <a:cs typeface="ＭＳ Ｐゴシック" panose="020B0600070205080204" pitchFamily="34" charset="-128"/>
-              </a:rPr>
-              <a:t>Mark 3:12</a:t>
-            </a:r>
-            <a:r>
-              <a:rPr lang="en-US" altLang="ja-JP" dirty="0">
-                <a:latin typeface="小塚明朝 Pro L"/>
-                <a:ea typeface="Meiryo UI" panose="020B0604030504040204" pitchFamily="34" charset="-128"/>
-                <a:cs typeface="ＭＳ Ｐゴシック" panose="020B0600070205080204" pitchFamily="34" charset="-128"/>
-              </a:rPr>
-              <a:t xml:space="preserve">  </a:t>
-            </a:r>
-            <a:r>
-              <a:rPr lang="ja-JP" altLang="ja-JP">
-                <a:latin typeface="小塚明朝 Pro L"/>
-                <a:ea typeface="Meiryo UI" panose="020B0604030504040204" pitchFamily="34" charset="-128"/>
-                <a:cs typeface="ＭＳ Ｐゴシック" panose="020B0600070205080204" pitchFamily="34" charset="-128"/>
-              </a:rPr>
-              <a:t>イエスはご自分のことを知らせないよう、彼らを厳しく戒められた。</a:t>
+              <a:t>Mark 5:34</a:t>
+            </a:r>
+            <a:r>
+              <a:rPr lang="en-US" altLang="ja-JP" dirty="0">
+                <a:latin typeface="小塚明朝 Pro L"/>
+                <a:ea typeface="Meiryo UI" panose="020B0604030504040204" pitchFamily="34" charset="-128"/>
+                <a:cs typeface="ＭＳ Ｐゴシック" panose="020B0600070205080204" pitchFamily="34" charset="-128"/>
+              </a:rPr>
+              <a:t xml:space="preserve">  </a:t>
+            </a:r>
+            <a:r>
+              <a:rPr lang="ja-JP" altLang="ja-JP">
+                <a:latin typeface="小塚明朝 Pro L"/>
+                <a:ea typeface="Meiryo UI" panose="020B0604030504040204" pitchFamily="34" charset="-128"/>
+                <a:cs typeface="ＭＳ Ｐゴシック" panose="020B0600070205080204" pitchFamily="34" charset="-128"/>
+              </a:rPr>
+              <a:t>イエスは彼女に言われた。「娘よ、あなたの信仰があなたを救ったのです。安心して行きなさい。苦しむことなく、健やかでいなさい。」</a:t>
             </a:r>
           </a:p>
           <a:p>
@@ -1280,23 +1254,50 @@
                 <a:ea typeface="Meiryo UI" panose="020B0604030504040204" pitchFamily="34" charset="-128"/>
                 <a:cs typeface="ＭＳ Ｐゴシック" panose="020B0600070205080204" pitchFamily="34" charset="-128"/>
               </a:rPr>
-              <a:t>Mark 1:1</a:t>
-            </a:r>
-            <a:r>
-              <a:rPr lang="en-US" altLang="ja-JP" dirty="0">
-                <a:latin typeface="小塚明朝 Pro L"/>
-                <a:ea typeface="Meiryo UI" panose="020B0604030504040204" pitchFamily="34" charset="-128"/>
-                <a:cs typeface="ＭＳ Ｐゴシック" panose="020B0600070205080204" pitchFamily="34" charset="-128"/>
-              </a:rPr>
-              <a:t xml:space="preserve">  </a:t>
-            </a:r>
-            <a:r>
-              <a:rPr lang="ja-JP" altLang="ja-JP">
-                <a:latin typeface="小塚明朝 Pro L"/>
-                <a:ea typeface="Meiryo UI" panose="020B0604030504040204" pitchFamily="34" charset="-128"/>
-                <a:cs typeface="ＭＳ Ｐゴシック" panose="020B0600070205080204" pitchFamily="34" charset="-128"/>
-              </a:rPr>
-              <a:t>神の子、イエス・キリストの福音のはじめ。</a:t>
+              <a:t>Mark 3:11</a:t>
+            </a:r>
+            <a:r>
+              <a:rPr lang="en-US" altLang="ja-JP" dirty="0">
+                <a:latin typeface="小塚明朝 Pro L"/>
+                <a:ea typeface="Meiryo UI" panose="020B0604030504040204" pitchFamily="34" charset="-128"/>
+                <a:cs typeface="ＭＳ Ｐゴシック" panose="020B0600070205080204" pitchFamily="34" charset="-128"/>
+              </a:rPr>
+              <a:t xml:space="preserve">  </a:t>
+            </a:r>
+            <a:r>
+              <a:rPr lang="ja-JP" altLang="ja-JP">
+                <a:latin typeface="小塚明朝 Pro L"/>
+                <a:ea typeface="Meiryo UI" panose="020B0604030504040204" pitchFamily="34" charset="-128"/>
+                <a:cs typeface="ＭＳ Ｐゴシック" panose="020B0600070205080204" pitchFamily="34" charset="-128"/>
+              </a:rPr>
+              <a:t>汚れた霊どもは、イエスを見るたびに御前にひれ伏して「あなたは神の子です」と叫んだ。</a:t>
+            </a:r>
+          </a:p>
+          <a:p>
+            <a:pPr marL="152400" marR="152400"/>
+            <a:r>
+              <a:rPr lang="en-US" altLang="ja-JP" dirty="0">
+                <a:latin typeface="小塚明朝 Pro L"/>
+                <a:ea typeface="Meiryo UI" panose="020B0604030504040204" pitchFamily="34" charset="-128"/>
+                <a:cs typeface="ＭＳ Ｐゴシック" panose="020B0600070205080204" pitchFamily="34" charset="-128"/>
+              </a:rPr>
+              <a:t>Mark 3:12</a:t>
+            </a:r>
+            <a:r>
+              <a:rPr lang="en-US" altLang="ja-JP" dirty="0">
+                <a:latin typeface="小塚明朝 Pro L"/>
+                <a:ea typeface="Meiryo UI" panose="020B0604030504040204" pitchFamily="34" charset="-128"/>
+                <a:cs typeface="ＭＳ Ｐゴシック" panose="020B0600070205080204" pitchFamily="34" charset="-128"/>
+              </a:rPr>
+              <a:t xml:space="preserve">  </a:t>
+            </a:r>
+            <a:r>
+              <a:rPr lang="ja-JP" altLang="ja-JP">
+                <a:latin typeface="小塚明朝 Pro L"/>
+                <a:ea typeface="Meiryo UI" panose="020B0604030504040204" pitchFamily="34" charset="-128"/>
+                <a:cs typeface="ＭＳ Ｐゴシック" panose="020B0600070205080204" pitchFamily="34" charset="-128"/>
+              </a:rPr>
+              <a:t>イエスはご自分のことを知らせないよう、彼らを厳しく戒められた。</a:t>
             </a:r>
           </a:p>
           <a:p>
@@ -1368,23 +1369,23 @@
                 <a:ea typeface="Meiryo UI" panose="020B0604030504040204" pitchFamily="34" charset="-128"/>
                 <a:cs typeface="ＭＳ Ｐゴシック" panose="020B0600070205080204" pitchFamily="34" charset="-128"/>
               </a:rPr>
-              <a:t>Mark 1:34</a:t>
-            </a:r>
-            <a:r>
-              <a:rPr lang="en-US" altLang="ja-JP" dirty="0">
-                <a:latin typeface="小塚明朝 Pro L"/>
-                <a:ea typeface="Meiryo UI" panose="020B0604030504040204" pitchFamily="34" charset="-128"/>
-                <a:cs typeface="ＭＳ Ｐゴシック" panose="020B0600070205080204" pitchFamily="34" charset="-128"/>
-              </a:rPr>
-              <a:t xml:space="preserve">  </a:t>
-            </a:r>
-            <a:r>
-              <a:rPr lang="ja-JP" altLang="ja-JP">
-                <a:latin typeface="小塚明朝 Pro L"/>
-                <a:ea typeface="Meiryo UI" panose="020B0604030504040204" pitchFamily="34" charset="-128"/>
-                <a:cs typeface="ＭＳ Ｐゴシック" panose="020B0600070205080204" pitchFamily="34" charset="-128"/>
-              </a:rPr>
-              <a:t>イエスは、様々な病気にかかっている多くの人を癒やされた。また、多くの悪霊を追い出し、悪霊どもがものを言うのをお許しにならなかった。彼らがイエスのことを知っていたからである。</a:t>
+              <a:t>Mark 1:1</a:t>
+            </a:r>
+            <a:r>
+              <a:rPr lang="en-US" altLang="ja-JP" dirty="0">
+                <a:latin typeface="小塚明朝 Pro L"/>
+                <a:ea typeface="Meiryo UI" panose="020B0604030504040204" pitchFamily="34" charset="-128"/>
+                <a:cs typeface="ＭＳ Ｐゴシック" panose="020B0600070205080204" pitchFamily="34" charset="-128"/>
+              </a:rPr>
+              <a:t xml:space="preserve">  </a:t>
+            </a:r>
+            <a:r>
+              <a:rPr lang="ja-JP" altLang="ja-JP">
+                <a:latin typeface="小塚明朝 Pro L"/>
+                <a:ea typeface="Meiryo UI" panose="020B0604030504040204" pitchFamily="34" charset="-128"/>
+                <a:cs typeface="ＭＳ Ｐゴシック" panose="020B0600070205080204" pitchFamily="34" charset="-128"/>
+              </a:rPr>
+              <a:t>神の子、イエス・キリストの福音のはじめ。</a:t>
             </a:r>
           </a:p>
           <a:p>
@@ -1456,50 +1457,23 @@
                 <a:ea typeface="Meiryo UI" panose="020B0604030504040204" pitchFamily="34" charset="-128"/>
                 <a:cs typeface="ＭＳ Ｐゴシック" panose="020B0600070205080204" pitchFamily="34" charset="-128"/>
               </a:rPr>
-              <a:t>Mark 14:61</a:t>
-            </a:r>
-            <a:r>
-              <a:rPr lang="en-US" altLang="ja-JP" dirty="0">
-                <a:latin typeface="小塚明朝 Pro L"/>
-                <a:ea typeface="Meiryo UI" panose="020B0604030504040204" pitchFamily="34" charset="-128"/>
-                <a:cs typeface="ＭＳ Ｐゴシック" panose="020B0600070205080204" pitchFamily="34" charset="-128"/>
-              </a:rPr>
-              <a:t xml:space="preserve">  </a:t>
-            </a:r>
-            <a:r>
-              <a:rPr lang="ja-JP" altLang="ja-JP">
-                <a:latin typeface="小塚明朝 Pro L"/>
-                <a:ea typeface="Meiryo UI" panose="020B0604030504040204" pitchFamily="34" charset="-128"/>
-                <a:cs typeface="ＭＳ Ｐゴシック" panose="020B0600070205080204" pitchFamily="34" charset="-128"/>
-              </a:rPr>
-              <a:t>しかし、イエスは黙ったまま、何もお答えにならなかった。大祭司は再びイエスに尋ねた。「おまえは、ほむべき方の子キリストなのか。」</a:t>
-            </a:r>
-          </a:p>
-          <a:p>
-            <a:pPr marL="152400" marR="152400"/>
-            <a:r>
-              <a:rPr lang="en-US" altLang="ja-JP" dirty="0">
-                <a:latin typeface="小塚明朝 Pro L"/>
-                <a:ea typeface="Meiryo UI" panose="020B0604030504040204" pitchFamily="34" charset="-128"/>
-                <a:cs typeface="ＭＳ Ｐゴシック" panose="020B0600070205080204" pitchFamily="34" charset="-128"/>
-              </a:rPr>
-              <a:t>Mark 14:62</a:t>
-            </a:r>
-            <a:r>
-              <a:rPr lang="en-US" altLang="ja-JP" dirty="0">
-                <a:latin typeface="小塚明朝 Pro L"/>
-                <a:ea typeface="Meiryo UI" panose="020B0604030504040204" pitchFamily="34" charset="-128"/>
-                <a:cs typeface="ＭＳ Ｐゴシック" panose="020B0600070205080204" pitchFamily="34" charset="-128"/>
-              </a:rPr>
-              <a:t xml:space="preserve">  </a:t>
-            </a:r>
-            <a:r>
-              <a:rPr lang="ja-JP" altLang="ja-JP">
-                <a:latin typeface="小塚明朝 Pro L"/>
-                <a:ea typeface="Meiryo UI" panose="020B0604030504040204" pitchFamily="34" charset="-128"/>
-                <a:cs typeface="ＭＳ Ｐゴシック" panose="020B0600070205080204" pitchFamily="34" charset="-128"/>
-              </a:rPr>
-              <a:t>そこでイエスは言われた。「わたしが、それです。あなたがたは、人の子が力ある方の右の座に着き、そして天の雲とともに来るのを見ることになります。」</a:t>
+              <a:t>Mark 1:34</a:t>
+            </a:r>
+            <a:r>
+              <a:rPr lang="en-US" altLang="ja-JP" dirty="0">
+                <a:latin typeface="小塚明朝 Pro L"/>
+                <a:ea typeface="Meiryo UI" panose="020B0604030504040204" pitchFamily="34" charset="-128"/>
+                <a:cs typeface="ＭＳ Ｐゴシック" panose="020B0600070205080204" pitchFamily="34" charset="-128"/>
+              </a:rPr>
+              <a:t xml:space="preserve">  </a:t>
+            </a:r>
+            <a:r>
+              <a:rPr lang="ja-JP" altLang="ja-JP">
+                <a:latin typeface="小塚明朝 Pro L"/>
+                <a:ea typeface="Meiryo UI" panose="020B0604030504040204" pitchFamily="34" charset="-128"/>
+                <a:cs typeface="ＭＳ Ｐゴシック" panose="020B0600070205080204" pitchFamily="34" charset="-128"/>
+              </a:rPr>
+              <a:t>イエスは、様々な病気にかかっている多くの人を癒やされた。また、多くの悪霊を追い出し、悪霊どもがものを言うのをお許しにならなかった。彼らがイエスのことを知っていたからである。</a:t>
             </a:r>
           </a:p>
           <a:p>
@@ -1571,23 +1545,50 @@
                 <a:ea typeface="Meiryo UI" panose="020B0604030504040204" pitchFamily="34" charset="-128"/>
                 <a:cs typeface="ＭＳ Ｐゴシック" panose="020B0600070205080204" pitchFamily="34" charset="-128"/>
               </a:rPr>
-              <a:t>Mark 3:13</a:t>
-            </a:r>
-            <a:r>
-              <a:rPr lang="en-US" altLang="ja-JP" dirty="0">
-                <a:latin typeface="小塚明朝 Pro L"/>
-                <a:ea typeface="Meiryo UI" panose="020B0604030504040204" pitchFamily="34" charset="-128"/>
-                <a:cs typeface="ＭＳ Ｐゴシック" panose="020B0600070205080204" pitchFamily="34" charset="-128"/>
-              </a:rPr>
-              <a:t xml:space="preserve">  </a:t>
-            </a:r>
-            <a:r>
-              <a:rPr lang="ja-JP" altLang="ja-JP">
-                <a:latin typeface="小塚明朝 Pro L"/>
-                <a:ea typeface="Meiryo UI" panose="020B0604030504040204" pitchFamily="34" charset="-128"/>
-                <a:cs typeface="ＭＳ Ｐゴシック" panose="020B0600070205080204" pitchFamily="34" charset="-128"/>
-              </a:rPr>
-              <a:t>さて、イエスが山に登り、ご自分が望む者たちを呼び寄せられると、彼らはみもとに来た。</a:t>
+              <a:t>Mark 14:61</a:t>
+            </a:r>
+            <a:r>
+              <a:rPr lang="en-US" altLang="ja-JP" dirty="0">
+                <a:latin typeface="小塚明朝 Pro L"/>
+                <a:ea typeface="Meiryo UI" panose="020B0604030504040204" pitchFamily="34" charset="-128"/>
+                <a:cs typeface="ＭＳ Ｐゴシック" panose="020B0600070205080204" pitchFamily="34" charset="-128"/>
+              </a:rPr>
+              <a:t xml:space="preserve">  </a:t>
+            </a:r>
+            <a:r>
+              <a:rPr lang="ja-JP" altLang="ja-JP">
+                <a:latin typeface="小塚明朝 Pro L"/>
+                <a:ea typeface="Meiryo UI" panose="020B0604030504040204" pitchFamily="34" charset="-128"/>
+                <a:cs typeface="ＭＳ Ｐゴシック" panose="020B0600070205080204" pitchFamily="34" charset="-128"/>
+              </a:rPr>
+              <a:t>しかし、イエスは黙ったまま、何もお答えにならなかった。大祭司は再びイエスに尋ねた。「おまえは、ほむべき方の子キリストなのか。」</a:t>
+            </a:r>
+          </a:p>
+          <a:p>
+            <a:pPr marL="152400" marR="152400"/>
+            <a:r>
+              <a:rPr lang="en-US" altLang="ja-JP" dirty="0">
+                <a:latin typeface="小塚明朝 Pro L"/>
+                <a:ea typeface="Meiryo UI" panose="020B0604030504040204" pitchFamily="34" charset="-128"/>
+                <a:cs typeface="ＭＳ Ｐゴシック" panose="020B0600070205080204" pitchFamily="34" charset="-128"/>
+              </a:rPr>
+              <a:t>Mark 14:62</a:t>
+            </a:r>
+            <a:r>
+              <a:rPr lang="en-US" altLang="ja-JP" dirty="0">
+                <a:latin typeface="小塚明朝 Pro L"/>
+                <a:ea typeface="Meiryo UI" panose="020B0604030504040204" pitchFamily="34" charset="-128"/>
+                <a:cs typeface="ＭＳ Ｐゴシック" panose="020B0600070205080204" pitchFamily="34" charset="-128"/>
+              </a:rPr>
+              <a:t xml:space="preserve">  </a:t>
+            </a:r>
+            <a:r>
+              <a:rPr lang="ja-JP" altLang="ja-JP">
+                <a:latin typeface="小塚明朝 Pro L"/>
+                <a:ea typeface="Meiryo UI" panose="020B0604030504040204" pitchFamily="34" charset="-128"/>
+                <a:cs typeface="ＭＳ Ｐゴシック" panose="020B0600070205080204" pitchFamily="34" charset="-128"/>
+              </a:rPr>
+              <a:t>そこでイエスは言われた。「わたしが、それです。あなたがたは、人の子が力ある方の右の座に着き、そして天の雲とともに来るのを見ることになります。」</a:t>
             </a:r>
           </a:p>
           <a:p>
@@ -1659,50 +1660,23 @@
                 <a:ea typeface="Meiryo UI" panose="020B0604030504040204" pitchFamily="34" charset="-128"/>
                 <a:cs typeface="ＭＳ Ｐゴシック" panose="020B0600070205080204" pitchFamily="34" charset="-128"/>
               </a:rPr>
-              <a:t>Mark 3:14</a:t>
-            </a:r>
-            <a:r>
-              <a:rPr lang="en-US" altLang="ja-JP" dirty="0">
-                <a:latin typeface="小塚明朝 Pro L"/>
-                <a:ea typeface="Meiryo UI" panose="020B0604030504040204" pitchFamily="34" charset="-128"/>
-                <a:cs typeface="ＭＳ Ｐゴシック" panose="020B0600070205080204" pitchFamily="34" charset="-128"/>
-              </a:rPr>
-              <a:t xml:space="preserve">  </a:t>
-            </a:r>
-            <a:r>
-              <a:rPr lang="ja-JP" altLang="ja-JP">
-                <a:latin typeface="小塚明朝 Pro L"/>
-                <a:ea typeface="Meiryo UI" panose="020B0604030504040204" pitchFamily="34" charset="-128"/>
-                <a:cs typeface="ＭＳ Ｐゴシック" panose="020B0600070205080204" pitchFamily="34" charset="-128"/>
-              </a:rPr>
-              <a:t>イエスは十二人を任命し、彼らを使徒と呼ばれた。それは、彼らをご自分のそばに置くため、また彼らを遣わして宣教をさせ、</a:t>
-            </a:r>
-          </a:p>
-          <a:p>
-            <a:pPr marL="152400" marR="152400"/>
-            <a:r>
-              <a:rPr lang="en-US" altLang="ja-JP" dirty="0">
-                <a:latin typeface="小塚明朝 Pro L"/>
-                <a:ea typeface="Meiryo UI" panose="020B0604030504040204" pitchFamily="34" charset="-128"/>
-                <a:cs typeface="ＭＳ Ｐゴシック" panose="020B0600070205080204" pitchFamily="34" charset="-128"/>
-              </a:rPr>
-              <a:t>Mark 3:15</a:t>
-            </a:r>
-            <a:r>
-              <a:rPr lang="en-US" altLang="ja-JP" dirty="0">
-                <a:latin typeface="小塚明朝 Pro L"/>
-                <a:ea typeface="Meiryo UI" panose="020B0604030504040204" pitchFamily="34" charset="-128"/>
-                <a:cs typeface="ＭＳ Ｐゴシック" panose="020B0600070205080204" pitchFamily="34" charset="-128"/>
-              </a:rPr>
-              <a:t xml:space="preserve">  </a:t>
-            </a:r>
-            <a:r>
-              <a:rPr lang="ja-JP" altLang="ja-JP">
-                <a:latin typeface="小塚明朝 Pro L"/>
-                <a:ea typeface="Meiryo UI" panose="020B0604030504040204" pitchFamily="34" charset="-128"/>
-                <a:cs typeface="ＭＳ Ｐゴシック" panose="020B0600070205080204" pitchFamily="34" charset="-128"/>
-              </a:rPr>
-              <a:t>彼らに悪霊を追い出す権威を持たせるためであった。</a:t>
+              <a:t>Mark 3:13</a:t>
+            </a:r>
+            <a:r>
+              <a:rPr lang="en-US" altLang="ja-JP" dirty="0">
+                <a:latin typeface="小塚明朝 Pro L"/>
+                <a:ea typeface="Meiryo UI" panose="020B0604030504040204" pitchFamily="34" charset="-128"/>
+                <a:cs typeface="ＭＳ Ｐゴシック" panose="020B0600070205080204" pitchFamily="34" charset="-128"/>
+              </a:rPr>
+              <a:t xml:space="preserve">  </a:t>
+            </a:r>
+            <a:r>
+              <a:rPr lang="ja-JP" altLang="ja-JP">
+                <a:latin typeface="小塚明朝 Pro L"/>
+                <a:ea typeface="Meiryo UI" panose="020B0604030504040204" pitchFamily="34" charset="-128"/>
+                <a:cs typeface="ＭＳ Ｐゴシック" panose="020B0600070205080204" pitchFamily="34" charset="-128"/>
+              </a:rPr>
+              <a:t>さて、イエスが山に登り、ご自分が望む者たちを呼び寄せられると、彼らはみもとに来た。</a:t>
             </a:r>
           </a:p>
           <a:p>
@@ -1774,77 +1748,50 @@
                 <a:ea typeface="Meiryo UI" panose="020B0604030504040204" pitchFamily="34" charset="-128"/>
                 <a:cs typeface="ＭＳ Ｐゴシック" panose="020B0600070205080204" pitchFamily="34" charset="-128"/>
               </a:rPr>
-              <a:t>Mark 6:7</a:t>
-            </a:r>
-            <a:r>
-              <a:rPr lang="en-US" altLang="ja-JP" dirty="0">
-                <a:latin typeface="小塚明朝 Pro L"/>
-                <a:ea typeface="Meiryo UI" panose="020B0604030504040204" pitchFamily="34" charset="-128"/>
-                <a:cs typeface="ＭＳ Ｐゴシック" panose="020B0600070205080204" pitchFamily="34" charset="-128"/>
-              </a:rPr>
-              <a:t xml:space="preserve">  </a:t>
-            </a:r>
-            <a:r>
-              <a:rPr lang="ja-JP" altLang="ja-JP">
-                <a:latin typeface="小塚明朝 Pro L"/>
-                <a:ea typeface="Meiryo UI" panose="020B0604030504040204" pitchFamily="34" charset="-128"/>
-                <a:cs typeface="ＭＳ Ｐゴシック" panose="020B0600070205080204" pitchFamily="34" charset="-128"/>
-              </a:rPr>
-              <a:t>また、十二人を呼び、二人ずつ遣わし始めて、彼らに汚れた霊を制する権威をお授けになった。</a:t>
-            </a:r>
-          </a:p>
-          <a:p>
-            <a:pPr marL="152400" marR="152400"/>
-            <a:r>
-              <a:rPr lang="en-US" altLang="ja-JP" dirty="0">
-                <a:latin typeface="小塚明朝 Pro L"/>
-                <a:ea typeface="Meiryo UI" panose="020B0604030504040204" pitchFamily="34" charset="-128"/>
-                <a:cs typeface="ＭＳ Ｐゴシック" panose="020B0600070205080204" pitchFamily="34" charset="-128"/>
-              </a:rPr>
-              <a:t>Mark 6:12</a:t>
-            </a:r>
-            <a:r>
-              <a:rPr lang="en-US" altLang="ja-JP" dirty="0">
-                <a:latin typeface="小塚明朝 Pro L"/>
-                <a:ea typeface="Meiryo UI" panose="020B0604030504040204" pitchFamily="34" charset="-128"/>
-                <a:cs typeface="ＭＳ Ｐゴシック" panose="020B0600070205080204" pitchFamily="34" charset="-128"/>
-              </a:rPr>
-              <a:t xml:space="preserve">  </a:t>
-            </a:r>
-            <a:r>
-              <a:rPr lang="ja-JP" altLang="ja-JP">
-                <a:latin typeface="小塚明朝 Pro L"/>
-                <a:ea typeface="Meiryo UI" panose="020B0604030504040204" pitchFamily="34" charset="-128"/>
-                <a:cs typeface="ＭＳ Ｐゴシック" panose="020B0600070205080204" pitchFamily="34" charset="-128"/>
-              </a:rPr>
-              <a:t>こうして十二人は出て行って、人々が悔い改めるように宣べ伝え、</a:t>
-            </a:r>
-          </a:p>
-          <a:p>
-            <a:pPr marL="152400" marR="152400"/>
-            <a:r>
-              <a:rPr lang="en-US" altLang="ja-JP" dirty="0">
-                <a:latin typeface="小塚明朝 Pro L"/>
-                <a:ea typeface="Meiryo UI" panose="020B0604030504040204" pitchFamily="34" charset="-128"/>
-                <a:cs typeface="ＭＳ Ｐゴシック" panose="020B0600070205080204" pitchFamily="34" charset="-128"/>
-              </a:rPr>
-              <a:t>Mark 6:13</a:t>
-            </a:r>
-            <a:r>
-              <a:rPr lang="en-US" altLang="ja-JP" dirty="0">
-                <a:latin typeface="小塚明朝 Pro L"/>
-                <a:ea typeface="Meiryo UI" panose="020B0604030504040204" pitchFamily="34" charset="-128"/>
-                <a:cs typeface="ＭＳ Ｐゴシック" panose="020B0600070205080204" pitchFamily="34" charset="-128"/>
-              </a:rPr>
-              <a:t xml:space="preserve">  </a:t>
-            </a:r>
-            <a:r>
-              <a:rPr lang="ja-JP" altLang="ja-JP">
-                <a:latin typeface="小塚明朝 Pro L"/>
-                <a:ea typeface="Meiryo UI" panose="020B0604030504040204" pitchFamily="34" charset="-128"/>
-                <a:cs typeface="ＭＳ Ｐゴシック" panose="020B0600070205080204" pitchFamily="34" charset="-128"/>
-              </a:rPr>
-              <a:t>多くの悪霊を追い出し、油を塗って多くの病人を癒やした。</a:t>
+              <a:t>Mark 3:14</a:t>
+            </a:r>
+            <a:r>
+              <a:rPr lang="en-US" altLang="ja-JP" dirty="0">
+                <a:latin typeface="小塚明朝 Pro L"/>
+                <a:ea typeface="Meiryo UI" panose="020B0604030504040204" pitchFamily="34" charset="-128"/>
+                <a:cs typeface="ＭＳ Ｐゴシック" panose="020B0600070205080204" pitchFamily="34" charset="-128"/>
+              </a:rPr>
+              <a:t xml:space="preserve">  </a:t>
+            </a:r>
+            <a:r>
+              <a:rPr lang="ja-JP" altLang="ja-JP">
+                <a:latin typeface="小塚明朝 Pro L"/>
+                <a:ea typeface="Meiryo UI" panose="020B0604030504040204" pitchFamily="34" charset="-128"/>
+                <a:cs typeface="ＭＳ Ｐゴシック" panose="020B0600070205080204" pitchFamily="34" charset="-128"/>
+              </a:rPr>
+              <a:t>イエスは十二人を任命し、彼らを使徒と呼ばれた。それは、彼らをご自分のそばに置くため、また彼らを遣わして宣教をさせ、</a:t>
+            </a:r>
+          </a:p>
+          <a:p>
+            <a:pPr marL="152400" marR="152400"/>
+            <a:r>
+              <a:rPr lang="en-US" altLang="ja-JP" dirty="0">
+                <a:latin typeface="小塚明朝 Pro L"/>
+                <a:ea typeface="Meiryo UI" panose="020B0604030504040204" pitchFamily="34" charset="-128"/>
+                <a:cs typeface="ＭＳ Ｐゴシック" panose="020B0600070205080204" pitchFamily="34" charset="-128"/>
+              </a:rPr>
+              <a:t>Mark 3:15</a:t>
+            </a:r>
+            <a:r>
+              <a:rPr lang="en-US" altLang="ja-JP" dirty="0">
+                <a:latin typeface="小塚明朝 Pro L"/>
+                <a:ea typeface="Meiryo UI" panose="020B0604030504040204" pitchFamily="34" charset="-128"/>
+                <a:cs typeface="ＭＳ Ｐゴシック" panose="020B0600070205080204" pitchFamily="34" charset="-128"/>
+              </a:rPr>
+              <a:t xml:space="preserve">  </a:t>
+            </a:r>
+            <a:r>
+              <a:rPr lang="ja-JP" altLang="ja-JP">
+                <a:latin typeface="小塚明朝 Pro L"/>
+                <a:ea typeface="Meiryo UI" panose="020B0604030504040204" pitchFamily="34" charset="-128"/>
+                <a:cs typeface="ＭＳ Ｐゴシック" panose="020B0600070205080204" pitchFamily="34" charset="-128"/>
+              </a:rPr>
+              <a:t>彼らに悪霊を追い出す権威を持たせるためであった。</a:t>
             </a:r>
           </a:p>
           <a:p>
@@ -1916,23 +1863,77 @@
                 <a:ea typeface="Meiryo UI" panose="020B0604030504040204" pitchFamily="34" charset="-128"/>
                 <a:cs typeface="ＭＳ Ｐゴシック" panose="020B0600070205080204" pitchFamily="34" charset="-128"/>
               </a:rPr>
-              <a:t>Mark 6:30</a:t>
-            </a:r>
-            <a:r>
-              <a:rPr lang="en-US" altLang="ja-JP" dirty="0">
-                <a:latin typeface="小塚明朝 Pro L"/>
-                <a:ea typeface="Meiryo UI" panose="020B0604030504040204" pitchFamily="34" charset="-128"/>
-                <a:cs typeface="ＭＳ Ｐゴシック" panose="020B0600070205080204" pitchFamily="34" charset="-128"/>
-              </a:rPr>
-              <a:t xml:space="preserve">  </a:t>
-            </a:r>
-            <a:r>
-              <a:rPr lang="ja-JP" altLang="ja-JP">
-                <a:latin typeface="小塚明朝 Pro L"/>
-                <a:ea typeface="Meiryo UI" panose="020B0604030504040204" pitchFamily="34" charset="-128"/>
-                <a:cs typeface="ＭＳ Ｐゴシック" panose="020B0600070205080204" pitchFamily="34" charset="-128"/>
-              </a:rPr>
-              <a:t>さて、使徒たちはイエスのもとに集まり、自分たちがしたこと、教えたことを、残らずイエスに報告した。</a:t>
+              <a:t>Mark 6:7</a:t>
+            </a:r>
+            <a:r>
+              <a:rPr lang="en-US" altLang="ja-JP" dirty="0">
+                <a:latin typeface="小塚明朝 Pro L"/>
+                <a:ea typeface="Meiryo UI" panose="020B0604030504040204" pitchFamily="34" charset="-128"/>
+                <a:cs typeface="ＭＳ Ｐゴシック" panose="020B0600070205080204" pitchFamily="34" charset="-128"/>
+              </a:rPr>
+              <a:t xml:space="preserve">  </a:t>
+            </a:r>
+            <a:r>
+              <a:rPr lang="ja-JP" altLang="ja-JP">
+                <a:latin typeface="小塚明朝 Pro L"/>
+                <a:ea typeface="Meiryo UI" panose="020B0604030504040204" pitchFamily="34" charset="-128"/>
+                <a:cs typeface="ＭＳ Ｐゴシック" panose="020B0600070205080204" pitchFamily="34" charset="-128"/>
+              </a:rPr>
+              <a:t>また、十二人を呼び、二人ずつ遣わし始めて、彼らに汚れた霊を制する権威をお授けになった。</a:t>
+            </a:r>
+          </a:p>
+          <a:p>
+            <a:pPr marL="152400" marR="152400"/>
+            <a:r>
+              <a:rPr lang="en-US" altLang="ja-JP" dirty="0">
+                <a:latin typeface="小塚明朝 Pro L"/>
+                <a:ea typeface="Meiryo UI" panose="020B0604030504040204" pitchFamily="34" charset="-128"/>
+                <a:cs typeface="ＭＳ Ｐゴシック" panose="020B0600070205080204" pitchFamily="34" charset="-128"/>
+              </a:rPr>
+              <a:t>Mark 6:12</a:t>
+            </a:r>
+            <a:r>
+              <a:rPr lang="en-US" altLang="ja-JP" dirty="0">
+                <a:latin typeface="小塚明朝 Pro L"/>
+                <a:ea typeface="Meiryo UI" panose="020B0604030504040204" pitchFamily="34" charset="-128"/>
+                <a:cs typeface="ＭＳ Ｐゴシック" panose="020B0600070205080204" pitchFamily="34" charset="-128"/>
+              </a:rPr>
+              <a:t xml:space="preserve">  </a:t>
+            </a:r>
+            <a:r>
+              <a:rPr lang="ja-JP" altLang="ja-JP">
+                <a:latin typeface="小塚明朝 Pro L"/>
+                <a:ea typeface="Meiryo UI" panose="020B0604030504040204" pitchFamily="34" charset="-128"/>
+                <a:cs typeface="ＭＳ Ｐゴシック" panose="020B0600070205080204" pitchFamily="34" charset="-128"/>
+              </a:rPr>
+              <a:t>こうして十二人は出て行って、人々が悔い改めるように宣べ伝え、</a:t>
+            </a:r>
+          </a:p>
+          <a:p>
+            <a:pPr marL="152400" marR="152400"/>
+            <a:r>
+              <a:rPr lang="en-US" altLang="ja-JP" dirty="0">
+                <a:latin typeface="小塚明朝 Pro L"/>
+                <a:ea typeface="Meiryo UI" panose="020B0604030504040204" pitchFamily="34" charset="-128"/>
+                <a:cs typeface="ＭＳ Ｐゴシック" panose="020B0600070205080204" pitchFamily="34" charset="-128"/>
+              </a:rPr>
+              <a:t>Mark 6:13</a:t>
+            </a:r>
+            <a:r>
+              <a:rPr lang="en-US" altLang="ja-JP" dirty="0">
+                <a:latin typeface="小塚明朝 Pro L"/>
+                <a:ea typeface="Meiryo UI" panose="020B0604030504040204" pitchFamily="34" charset="-128"/>
+                <a:cs typeface="ＭＳ Ｐゴシック" panose="020B0600070205080204" pitchFamily="34" charset="-128"/>
+              </a:rPr>
+              <a:t xml:space="preserve">  </a:t>
+            </a:r>
+            <a:r>
+              <a:rPr lang="ja-JP" altLang="ja-JP">
+                <a:latin typeface="小塚明朝 Pro L"/>
+                <a:ea typeface="Meiryo UI" panose="020B0604030504040204" pitchFamily="34" charset="-128"/>
+                <a:cs typeface="ＭＳ Ｐゴシック" panose="020B0600070205080204" pitchFamily="34" charset="-128"/>
+              </a:rPr>
+              <a:t>多くの悪霊を追い出し、油を塗って多くの病人を癒やした。</a:t>
             </a:r>
           </a:p>
           <a:p>
@@ -2119,23 +2120,23 @@
                 <a:ea typeface="Meiryo UI" panose="020B0604030504040204" pitchFamily="34" charset="-128"/>
                 <a:cs typeface="ＭＳ Ｐゴシック" panose="020B0600070205080204" pitchFamily="34" charset="-128"/>
               </a:rPr>
-              <a:t>Mark 6:31</a:t>
-            </a:r>
-            <a:r>
-              <a:rPr lang="en-US" altLang="ja-JP" dirty="0">
-                <a:latin typeface="小塚明朝 Pro L"/>
-                <a:ea typeface="Meiryo UI" panose="020B0604030504040204" pitchFamily="34" charset="-128"/>
-                <a:cs typeface="ＭＳ Ｐゴシック" panose="020B0600070205080204" pitchFamily="34" charset="-128"/>
-              </a:rPr>
-              <a:t xml:space="preserve">  </a:t>
-            </a:r>
-            <a:r>
-              <a:rPr lang="ja-JP" altLang="ja-JP">
-                <a:latin typeface="小塚明朝 Pro L"/>
-                <a:ea typeface="Meiryo UI" panose="020B0604030504040204" pitchFamily="34" charset="-128"/>
-                <a:cs typeface="ＭＳ Ｐゴシック" panose="020B0600070205080204" pitchFamily="34" charset="-128"/>
-              </a:rPr>
-              <a:t>するとイエスは彼らに言われた。「さあ、あなたがただけで、寂しいところへ行って、しばらく休みなさい。」出入りする人が多くて、食事をとる時間さえなかったからである。</a:t>
+              <a:t>Mark 6:30</a:t>
+            </a:r>
+            <a:r>
+              <a:rPr lang="en-US" altLang="ja-JP" dirty="0">
+                <a:latin typeface="小塚明朝 Pro L"/>
+                <a:ea typeface="Meiryo UI" panose="020B0604030504040204" pitchFamily="34" charset="-128"/>
+                <a:cs typeface="ＭＳ Ｐゴシック" panose="020B0600070205080204" pitchFamily="34" charset="-128"/>
+              </a:rPr>
+              <a:t xml:space="preserve">  </a:t>
+            </a:r>
+            <a:r>
+              <a:rPr lang="ja-JP" altLang="ja-JP">
+                <a:latin typeface="小塚明朝 Pro L"/>
+                <a:ea typeface="Meiryo UI" panose="020B0604030504040204" pitchFamily="34" charset="-128"/>
+                <a:cs typeface="ＭＳ Ｐゴシック" panose="020B0600070205080204" pitchFamily="34" charset="-128"/>
+              </a:rPr>
+              <a:t>さて、使徒たちはイエスのもとに集まり、自分たちがしたこと、教えたことを、残らずイエスに報告した。</a:t>
             </a:r>
           </a:p>
           <a:p>
@@ -2207,50 +2208,23 @@
                 <a:ea typeface="Meiryo UI" panose="020B0604030504040204" pitchFamily="34" charset="-128"/>
                 <a:cs typeface="ＭＳ Ｐゴシック" panose="020B0600070205080204" pitchFamily="34" charset="-128"/>
               </a:rPr>
-              <a:t>Mark 3:16</a:t>
-            </a:r>
-            <a:r>
-              <a:rPr lang="en-US" altLang="ja-JP" dirty="0">
-                <a:latin typeface="小塚明朝 Pro L"/>
-                <a:ea typeface="Meiryo UI" panose="020B0604030504040204" pitchFamily="34" charset="-128"/>
-                <a:cs typeface="ＭＳ Ｐゴシック" panose="020B0600070205080204" pitchFamily="34" charset="-128"/>
-              </a:rPr>
-              <a:t xml:space="preserve">  </a:t>
-            </a:r>
-            <a:r>
-              <a:rPr lang="ja-JP" altLang="ja-JP">
-                <a:latin typeface="小塚明朝 Pro L"/>
-                <a:ea typeface="Meiryo UI" panose="020B0604030504040204" pitchFamily="34" charset="-128"/>
-                <a:cs typeface="ＭＳ Ｐゴシック" panose="020B0600070205080204" pitchFamily="34" charset="-128"/>
-              </a:rPr>
-              <a:t>こうしてイエスは十二人を任命された。シモンにはペテロという名をつけ、</a:t>
-            </a:r>
-          </a:p>
-          <a:p>
-            <a:pPr marL="152400" marR="152400"/>
-            <a:r>
-              <a:rPr lang="en-US" altLang="ja-JP" dirty="0">
-                <a:latin typeface="小塚明朝 Pro L"/>
-                <a:ea typeface="Meiryo UI" panose="020B0604030504040204" pitchFamily="34" charset="-128"/>
-                <a:cs typeface="ＭＳ Ｐゴシック" panose="020B0600070205080204" pitchFamily="34" charset="-128"/>
-              </a:rPr>
-              <a:t>Mark 3:17</a:t>
-            </a:r>
-            <a:r>
-              <a:rPr lang="en-US" altLang="ja-JP" dirty="0">
-                <a:latin typeface="小塚明朝 Pro L"/>
-                <a:ea typeface="Meiryo UI" panose="020B0604030504040204" pitchFamily="34" charset="-128"/>
-                <a:cs typeface="ＭＳ Ｐゴシック" panose="020B0600070205080204" pitchFamily="34" charset="-128"/>
-              </a:rPr>
-              <a:t xml:space="preserve">  </a:t>
-            </a:r>
-            <a:r>
-              <a:rPr lang="ja-JP" altLang="ja-JP">
-                <a:latin typeface="小塚明朝 Pro L"/>
-                <a:ea typeface="Meiryo UI" panose="020B0604030504040204" pitchFamily="34" charset="-128"/>
-                <a:cs typeface="ＭＳ Ｐゴシック" panose="020B0600070205080204" pitchFamily="34" charset="-128"/>
-              </a:rPr>
-              <a:t>ゼベダイの子ヤコブと、ヤコブの兄弟ヨハネ、この二人にはボアネルゲ、すなわち、雷の子という名をつけられた。</a:t>
+              <a:t>Mark 6:31</a:t>
+            </a:r>
+            <a:r>
+              <a:rPr lang="en-US" altLang="ja-JP" dirty="0">
+                <a:latin typeface="小塚明朝 Pro L"/>
+                <a:ea typeface="Meiryo UI" panose="020B0604030504040204" pitchFamily="34" charset="-128"/>
+                <a:cs typeface="ＭＳ Ｐゴシック" panose="020B0600070205080204" pitchFamily="34" charset="-128"/>
+              </a:rPr>
+              <a:t xml:space="preserve">  </a:t>
+            </a:r>
+            <a:r>
+              <a:rPr lang="ja-JP" altLang="ja-JP">
+                <a:latin typeface="小塚明朝 Pro L"/>
+                <a:ea typeface="Meiryo UI" panose="020B0604030504040204" pitchFamily="34" charset="-128"/>
+                <a:cs typeface="ＭＳ Ｐゴシック" panose="020B0600070205080204" pitchFamily="34" charset="-128"/>
+              </a:rPr>
+              <a:t>するとイエスは彼らに言われた。「さあ、あなたがただけで、寂しいところへ行って、しばらく休みなさい。」出入りする人が多くて、食事をとる時間さえなかったからである。</a:t>
             </a:r>
           </a:p>
           <a:p>
@@ -2322,23 +2296,50 @@
                 <a:ea typeface="Meiryo UI" panose="020B0604030504040204" pitchFamily="34" charset="-128"/>
                 <a:cs typeface="ＭＳ Ｐゴシック" panose="020B0600070205080204" pitchFamily="34" charset="-128"/>
               </a:rPr>
-              <a:t>Mark 10:37</a:t>
-            </a:r>
-            <a:r>
-              <a:rPr lang="en-US" altLang="ja-JP" dirty="0">
-                <a:latin typeface="小塚明朝 Pro L"/>
-                <a:ea typeface="Meiryo UI" panose="020B0604030504040204" pitchFamily="34" charset="-128"/>
-                <a:cs typeface="ＭＳ Ｐゴシック" panose="020B0600070205080204" pitchFamily="34" charset="-128"/>
-              </a:rPr>
-              <a:t xml:space="preserve">  </a:t>
-            </a:r>
-            <a:r>
-              <a:rPr lang="ja-JP" altLang="ja-JP">
-                <a:latin typeface="小塚明朝 Pro L"/>
-                <a:ea typeface="Meiryo UI" panose="020B0604030504040204" pitchFamily="34" charset="-128"/>
-                <a:cs typeface="ＭＳ Ｐゴシック" panose="020B0600070205080204" pitchFamily="34" charset="-128"/>
-              </a:rPr>
-              <a:t>彼らは言った。「あなたが栄光をお受けになるとき、一人があなたの右に、もう一人が左に座るようにしてください。」</a:t>
+              <a:t>Mark 3:16</a:t>
+            </a:r>
+            <a:r>
+              <a:rPr lang="en-US" altLang="ja-JP" dirty="0">
+                <a:latin typeface="小塚明朝 Pro L"/>
+                <a:ea typeface="Meiryo UI" panose="020B0604030504040204" pitchFamily="34" charset="-128"/>
+                <a:cs typeface="ＭＳ Ｐゴシック" panose="020B0600070205080204" pitchFamily="34" charset="-128"/>
+              </a:rPr>
+              <a:t xml:space="preserve">  </a:t>
+            </a:r>
+            <a:r>
+              <a:rPr lang="ja-JP" altLang="ja-JP">
+                <a:latin typeface="小塚明朝 Pro L"/>
+                <a:ea typeface="Meiryo UI" panose="020B0604030504040204" pitchFamily="34" charset="-128"/>
+                <a:cs typeface="ＭＳ Ｐゴシック" panose="020B0600070205080204" pitchFamily="34" charset="-128"/>
+              </a:rPr>
+              <a:t>こうしてイエスは十二人を任命された。シモンにはペテロという名をつけ、</a:t>
+            </a:r>
+          </a:p>
+          <a:p>
+            <a:pPr marL="152400" marR="152400"/>
+            <a:r>
+              <a:rPr lang="en-US" altLang="ja-JP" dirty="0">
+                <a:latin typeface="小塚明朝 Pro L"/>
+                <a:ea typeface="Meiryo UI" panose="020B0604030504040204" pitchFamily="34" charset="-128"/>
+                <a:cs typeface="ＭＳ Ｐゴシック" panose="020B0600070205080204" pitchFamily="34" charset="-128"/>
+              </a:rPr>
+              <a:t>Mark 3:17</a:t>
+            </a:r>
+            <a:r>
+              <a:rPr lang="en-US" altLang="ja-JP" dirty="0">
+                <a:latin typeface="小塚明朝 Pro L"/>
+                <a:ea typeface="Meiryo UI" panose="020B0604030504040204" pitchFamily="34" charset="-128"/>
+                <a:cs typeface="ＭＳ Ｐゴシック" panose="020B0600070205080204" pitchFamily="34" charset="-128"/>
+              </a:rPr>
+              <a:t xml:space="preserve">  </a:t>
+            </a:r>
+            <a:r>
+              <a:rPr lang="ja-JP" altLang="ja-JP">
+                <a:latin typeface="小塚明朝 Pro L"/>
+                <a:ea typeface="Meiryo UI" panose="020B0604030504040204" pitchFamily="34" charset="-128"/>
+                <a:cs typeface="ＭＳ Ｐゴシック" panose="020B0600070205080204" pitchFamily="34" charset="-128"/>
+              </a:rPr>
+              <a:t>ゼベダイの子ヤコブと、ヤコブの兄弟ヨハネ、この二人にはボアネルゲ、すなわち、雷の子という名をつけられた。</a:t>
             </a:r>
           </a:p>
           <a:p>
@@ -2410,50 +2411,23 @@
                 <a:ea typeface="Meiryo UI" panose="020B0604030504040204" pitchFamily="34" charset="-128"/>
                 <a:cs typeface="ＭＳ Ｐゴシック" panose="020B0600070205080204" pitchFamily="34" charset="-128"/>
               </a:rPr>
-              <a:t>Mark 3:18</a:t>
-            </a:r>
-            <a:r>
-              <a:rPr lang="en-US" altLang="ja-JP" dirty="0">
-                <a:latin typeface="小塚明朝 Pro L"/>
-                <a:ea typeface="Meiryo UI" panose="020B0604030504040204" pitchFamily="34" charset="-128"/>
-                <a:cs typeface="ＭＳ Ｐゴシック" panose="020B0600070205080204" pitchFamily="34" charset="-128"/>
-              </a:rPr>
-              <a:t xml:space="preserve">  </a:t>
-            </a:r>
-            <a:r>
-              <a:rPr lang="ja-JP" altLang="ja-JP">
-                <a:latin typeface="小塚明朝 Pro L"/>
-                <a:ea typeface="Meiryo UI" panose="020B0604030504040204" pitchFamily="34" charset="-128"/>
-                <a:cs typeface="ＭＳ Ｐゴシック" panose="020B0600070205080204" pitchFamily="34" charset="-128"/>
-              </a:rPr>
-              <a:t>さらに、アンデレ、ピリポ、バルトロマイ、マタイ、トマス、アルパヨの子ヤコブ、タダイ、熱心党のシモン、</a:t>
-            </a:r>
-          </a:p>
-          <a:p>
-            <a:pPr marL="152400" marR="152400"/>
-            <a:r>
-              <a:rPr lang="en-US" altLang="ja-JP" dirty="0">
-                <a:latin typeface="小塚明朝 Pro L"/>
-                <a:ea typeface="Meiryo UI" panose="020B0604030504040204" pitchFamily="34" charset="-128"/>
-                <a:cs typeface="ＭＳ Ｐゴシック" panose="020B0600070205080204" pitchFamily="34" charset="-128"/>
-              </a:rPr>
-              <a:t>Mark 3:19</a:t>
-            </a:r>
-            <a:r>
-              <a:rPr lang="en-US" altLang="ja-JP" dirty="0">
-                <a:latin typeface="小塚明朝 Pro L"/>
-                <a:ea typeface="Meiryo UI" panose="020B0604030504040204" pitchFamily="34" charset="-128"/>
-                <a:cs typeface="ＭＳ Ｐゴシック" panose="020B0600070205080204" pitchFamily="34" charset="-128"/>
-              </a:rPr>
-              <a:t xml:space="preserve">  </a:t>
-            </a:r>
-            <a:r>
-              <a:rPr lang="ja-JP" altLang="ja-JP">
-                <a:latin typeface="小塚明朝 Pro L"/>
-                <a:ea typeface="Meiryo UI" panose="020B0604030504040204" pitchFamily="34" charset="-128"/>
-                <a:cs typeface="ＭＳ Ｐゴシック" panose="020B0600070205080204" pitchFamily="34" charset="-128"/>
-              </a:rPr>
-              <a:t>イスカリオテのユダを任命された。このユダがイエスを裏切ったのである。</a:t>
+              <a:t>Mark 10:37</a:t>
+            </a:r>
+            <a:r>
+              <a:rPr lang="en-US" altLang="ja-JP" dirty="0">
+                <a:latin typeface="小塚明朝 Pro L"/>
+                <a:ea typeface="Meiryo UI" panose="020B0604030504040204" pitchFamily="34" charset="-128"/>
+                <a:cs typeface="ＭＳ Ｐゴシック" panose="020B0600070205080204" pitchFamily="34" charset="-128"/>
+              </a:rPr>
+              <a:t xml:space="preserve">  </a:t>
+            </a:r>
+            <a:r>
+              <a:rPr lang="ja-JP" altLang="ja-JP">
+                <a:latin typeface="小塚明朝 Pro L"/>
+                <a:ea typeface="Meiryo UI" panose="020B0604030504040204" pitchFamily="34" charset="-128"/>
+                <a:cs typeface="ＭＳ Ｐゴシック" panose="020B0600070205080204" pitchFamily="34" charset="-128"/>
+              </a:rPr>
+              <a:t>彼らは言った。「あなたが栄光をお受けになるとき、一人があなたの右に、もう一人が左に座るようにしてください。」</a:t>
             </a:r>
           </a:p>
           <a:p>
@@ -2525,50 +2499,50 @@
                 <a:ea typeface="Meiryo UI" panose="020B0604030504040204" pitchFamily="34" charset="-128"/>
                 <a:cs typeface="ＭＳ Ｐゴシック" panose="020B0600070205080204" pitchFamily="34" charset="-128"/>
               </a:rPr>
-              <a:t>Mark 14:27</a:t>
-            </a:r>
-            <a:r>
-              <a:rPr lang="en-US" altLang="ja-JP" dirty="0">
-                <a:latin typeface="小塚明朝 Pro L"/>
-                <a:ea typeface="Meiryo UI" panose="020B0604030504040204" pitchFamily="34" charset="-128"/>
-                <a:cs typeface="ＭＳ Ｐゴシック" panose="020B0600070205080204" pitchFamily="34" charset="-128"/>
-              </a:rPr>
-              <a:t xml:space="preserve">  </a:t>
-            </a:r>
-            <a:r>
-              <a:rPr lang="ja-JP" altLang="ja-JP">
-                <a:latin typeface="小塚明朝 Pro L"/>
-                <a:ea typeface="Meiryo UI" panose="020B0604030504040204" pitchFamily="34" charset="-128"/>
-                <a:cs typeface="ＭＳ Ｐゴシック" panose="020B0600070205080204" pitchFamily="34" charset="-128"/>
-              </a:rPr>
-              <a:t>イエスは弟子たちに言われた。「あなたがたはみな、つまずきます。 『わたしは羊飼いを打つ。 すると、羊は散らされる』 と書いてあるからです。</a:t>
-            </a:r>
-          </a:p>
-          <a:p>
-            <a:pPr marL="152400" marR="152400"/>
-            <a:r>
-              <a:rPr lang="en-US" altLang="ja-JP" dirty="0">
-                <a:latin typeface="小塚明朝 Pro L"/>
-                <a:ea typeface="Meiryo UI" panose="020B0604030504040204" pitchFamily="34" charset="-128"/>
-                <a:cs typeface="ＭＳ Ｐゴシック" panose="020B0600070205080204" pitchFamily="34" charset="-128"/>
-              </a:rPr>
-              <a:t>Mark 14:28</a:t>
-            </a:r>
-            <a:r>
-              <a:rPr lang="en-US" altLang="ja-JP" dirty="0">
-                <a:latin typeface="小塚明朝 Pro L"/>
-                <a:ea typeface="Meiryo UI" panose="020B0604030504040204" pitchFamily="34" charset="-128"/>
-                <a:cs typeface="ＭＳ Ｐゴシック" panose="020B0600070205080204" pitchFamily="34" charset="-128"/>
-              </a:rPr>
-              <a:t xml:space="preserve">  </a:t>
-            </a:r>
-            <a:r>
-              <a:rPr lang="ja-JP" altLang="ja-JP">
-                <a:latin typeface="小塚明朝 Pro L"/>
-                <a:ea typeface="Meiryo UI" panose="020B0604030504040204" pitchFamily="34" charset="-128"/>
-                <a:cs typeface="ＭＳ Ｐゴシック" panose="020B0600070205080204" pitchFamily="34" charset="-128"/>
-              </a:rPr>
-              <a:t>しかしわたしは、よみがえった後、あなたがたより先にガリラヤへ行きます。」</a:t>
+              <a:t>Mark 3:18</a:t>
+            </a:r>
+            <a:r>
+              <a:rPr lang="en-US" altLang="ja-JP" dirty="0">
+                <a:latin typeface="小塚明朝 Pro L"/>
+                <a:ea typeface="Meiryo UI" panose="020B0604030504040204" pitchFamily="34" charset="-128"/>
+                <a:cs typeface="ＭＳ Ｐゴシック" panose="020B0600070205080204" pitchFamily="34" charset="-128"/>
+              </a:rPr>
+              <a:t xml:space="preserve">  </a:t>
+            </a:r>
+            <a:r>
+              <a:rPr lang="ja-JP" altLang="ja-JP">
+                <a:latin typeface="小塚明朝 Pro L"/>
+                <a:ea typeface="Meiryo UI" panose="020B0604030504040204" pitchFamily="34" charset="-128"/>
+                <a:cs typeface="ＭＳ Ｐゴシック" panose="020B0600070205080204" pitchFamily="34" charset="-128"/>
+              </a:rPr>
+              <a:t>さらに、アンデレ、ピリポ、バルトロマイ、マタイ、トマス、アルパヨの子ヤコブ、タダイ、熱心党のシモン、</a:t>
+            </a:r>
+          </a:p>
+          <a:p>
+            <a:pPr marL="152400" marR="152400"/>
+            <a:r>
+              <a:rPr lang="en-US" altLang="ja-JP" dirty="0">
+                <a:latin typeface="小塚明朝 Pro L"/>
+                <a:ea typeface="Meiryo UI" panose="020B0604030504040204" pitchFamily="34" charset="-128"/>
+                <a:cs typeface="ＭＳ Ｐゴシック" panose="020B0600070205080204" pitchFamily="34" charset="-128"/>
+              </a:rPr>
+              <a:t>Mark 3:19</a:t>
+            </a:r>
+            <a:r>
+              <a:rPr lang="en-US" altLang="ja-JP" dirty="0">
+                <a:latin typeface="小塚明朝 Pro L"/>
+                <a:ea typeface="Meiryo UI" panose="020B0604030504040204" pitchFamily="34" charset="-128"/>
+                <a:cs typeface="ＭＳ Ｐゴシック" panose="020B0600070205080204" pitchFamily="34" charset="-128"/>
+              </a:rPr>
+              <a:t xml:space="preserve">  </a:t>
+            </a:r>
+            <a:r>
+              <a:rPr lang="ja-JP" altLang="ja-JP">
+                <a:latin typeface="小塚明朝 Pro L"/>
+                <a:ea typeface="Meiryo UI" panose="020B0604030504040204" pitchFamily="34" charset="-128"/>
+                <a:cs typeface="ＭＳ Ｐゴシック" panose="020B0600070205080204" pitchFamily="34" charset="-128"/>
+              </a:rPr>
+              <a:t>イスカリオテのユダを任命された。このユダがイエスを裏切ったのである。</a:t>
             </a:r>
           </a:p>
           <a:p>
@@ -2640,23 +2614,50 @@
                 <a:ea typeface="Meiryo UI" panose="020B0604030504040204" pitchFamily="34" charset="-128"/>
                 <a:cs typeface="ＭＳ Ｐゴシック" panose="020B0600070205080204" pitchFamily="34" charset="-128"/>
               </a:rPr>
-              <a:t>Mark 14:50</a:t>
-            </a:r>
-            <a:r>
-              <a:rPr lang="en-US" altLang="ja-JP" dirty="0">
-                <a:latin typeface="小塚明朝 Pro L"/>
-                <a:ea typeface="Meiryo UI" panose="020B0604030504040204" pitchFamily="34" charset="-128"/>
-                <a:cs typeface="ＭＳ Ｐゴシック" panose="020B0600070205080204" pitchFamily="34" charset="-128"/>
-              </a:rPr>
-              <a:t xml:space="preserve">  </a:t>
-            </a:r>
-            <a:r>
-              <a:rPr lang="ja-JP" altLang="ja-JP">
-                <a:latin typeface="小塚明朝 Pro L"/>
-                <a:ea typeface="Meiryo UI" panose="020B0604030504040204" pitchFamily="34" charset="-128"/>
-                <a:cs typeface="ＭＳ Ｐゴシック" panose="020B0600070205080204" pitchFamily="34" charset="-128"/>
-              </a:rPr>
-              <a:t>皆は、イエスを見捨てて逃げてしまった。</a:t>
+              <a:t>Mark 14:27</a:t>
+            </a:r>
+            <a:r>
+              <a:rPr lang="en-US" altLang="ja-JP" dirty="0">
+                <a:latin typeface="小塚明朝 Pro L"/>
+                <a:ea typeface="Meiryo UI" panose="020B0604030504040204" pitchFamily="34" charset="-128"/>
+                <a:cs typeface="ＭＳ Ｐゴシック" panose="020B0600070205080204" pitchFamily="34" charset="-128"/>
+              </a:rPr>
+              <a:t xml:space="preserve">  </a:t>
+            </a:r>
+            <a:r>
+              <a:rPr lang="ja-JP" altLang="ja-JP">
+                <a:latin typeface="小塚明朝 Pro L"/>
+                <a:ea typeface="Meiryo UI" panose="020B0604030504040204" pitchFamily="34" charset="-128"/>
+                <a:cs typeface="ＭＳ Ｐゴシック" panose="020B0600070205080204" pitchFamily="34" charset="-128"/>
+              </a:rPr>
+              <a:t>イエスは弟子たちに言われた。「あなたがたはみな、つまずきます。 『わたしは羊飼いを打つ。 すると、羊は散らされる』 と書いてあるからです。</a:t>
+            </a:r>
+          </a:p>
+          <a:p>
+            <a:pPr marL="152400" marR="152400"/>
+            <a:r>
+              <a:rPr lang="en-US" altLang="ja-JP" dirty="0">
+                <a:latin typeface="小塚明朝 Pro L"/>
+                <a:ea typeface="Meiryo UI" panose="020B0604030504040204" pitchFamily="34" charset="-128"/>
+                <a:cs typeface="ＭＳ Ｐゴシック" panose="020B0600070205080204" pitchFamily="34" charset="-128"/>
+              </a:rPr>
+              <a:t>Mark 14:28</a:t>
+            </a:r>
+            <a:r>
+              <a:rPr lang="en-US" altLang="ja-JP" dirty="0">
+                <a:latin typeface="小塚明朝 Pro L"/>
+                <a:ea typeface="Meiryo UI" panose="020B0604030504040204" pitchFamily="34" charset="-128"/>
+                <a:cs typeface="ＭＳ Ｐゴシック" panose="020B0600070205080204" pitchFamily="34" charset="-128"/>
+              </a:rPr>
+              <a:t xml:space="preserve">  </a:t>
+            </a:r>
+            <a:r>
+              <a:rPr lang="ja-JP" altLang="ja-JP">
+                <a:latin typeface="小塚明朝 Pro L"/>
+                <a:ea typeface="Meiryo UI" panose="020B0604030504040204" pitchFamily="34" charset="-128"/>
+                <a:cs typeface="ＭＳ Ｐゴシック" panose="020B0600070205080204" pitchFamily="34" charset="-128"/>
+              </a:rPr>
+              <a:t>しかしわたしは、よみがえった後、あなたがたより先にガリラヤへ行きます。」</a:t>
             </a:r>
           </a:p>
           <a:p>
@@ -2728,23 +2729,23 @@
                 <a:ea typeface="Meiryo UI" panose="020B0604030504040204" pitchFamily="34" charset="-128"/>
                 <a:cs typeface="ＭＳ Ｐゴシック" panose="020B0600070205080204" pitchFamily="34" charset="-128"/>
               </a:rPr>
-              <a:t>Mark 16:7</a:t>
-            </a:r>
-            <a:r>
-              <a:rPr lang="en-US" altLang="ja-JP" dirty="0">
-                <a:latin typeface="小塚明朝 Pro L"/>
-                <a:ea typeface="Meiryo UI" panose="020B0604030504040204" pitchFamily="34" charset="-128"/>
-                <a:cs typeface="ＭＳ Ｐゴシック" panose="020B0600070205080204" pitchFamily="34" charset="-128"/>
-              </a:rPr>
-              <a:t xml:space="preserve">  </a:t>
-            </a:r>
-            <a:r>
-              <a:rPr lang="ja-JP" altLang="ja-JP">
-                <a:latin typeface="小塚明朝 Pro L"/>
-                <a:ea typeface="Meiryo UI" panose="020B0604030504040204" pitchFamily="34" charset="-128"/>
-                <a:cs typeface="ＭＳ Ｐゴシック" panose="020B0600070205080204" pitchFamily="34" charset="-128"/>
-              </a:rPr>
-              <a:t>さあ行って、弟子たちとペテロに伝えなさい。『イエスは、あなたがたより先にガリラヤへ行かれます。前に言われたとおり、そこでお会いできます』と。」</a:t>
+              <a:t>Mark 14:50</a:t>
+            </a:r>
+            <a:r>
+              <a:rPr lang="en-US" altLang="ja-JP" dirty="0">
+                <a:latin typeface="小塚明朝 Pro L"/>
+                <a:ea typeface="Meiryo UI" panose="020B0604030504040204" pitchFamily="34" charset="-128"/>
+                <a:cs typeface="ＭＳ Ｐゴシック" panose="020B0600070205080204" pitchFamily="34" charset="-128"/>
+              </a:rPr>
+              <a:t xml:space="preserve">  </a:t>
+            </a:r>
+            <a:r>
+              <a:rPr lang="ja-JP" altLang="ja-JP">
+                <a:latin typeface="小塚明朝 Pro L"/>
+                <a:ea typeface="Meiryo UI" panose="020B0604030504040204" pitchFamily="34" charset="-128"/>
+                <a:cs typeface="ＭＳ Ｐゴシック" panose="020B0600070205080204" pitchFamily="34" charset="-128"/>
+              </a:rPr>
+              <a:t>皆は、イエスを見捨てて逃げてしまった。</a:t>
             </a:r>
           </a:p>
           <a:p>
@@ -2816,50 +2817,23 @@
                 <a:ea typeface="Meiryo UI" panose="020B0604030504040204" pitchFamily="34" charset="-128"/>
                 <a:cs typeface="ＭＳ Ｐゴシック" panose="020B0600070205080204" pitchFamily="34" charset="-128"/>
               </a:rPr>
-              <a:t>Mark 3:14</a:t>
-            </a:r>
-            <a:r>
-              <a:rPr lang="en-US" altLang="ja-JP" dirty="0">
-                <a:latin typeface="小塚明朝 Pro L"/>
-                <a:ea typeface="Meiryo UI" panose="020B0604030504040204" pitchFamily="34" charset="-128"/>
-                <a:cs typeface="ＭＳ Ｐゴシック" panose="020B0600070205080204" pitchFamily="34" charset="-128"/>
-              </a:rPr>
-              <a:t xml:space="preserve">  </a:t>
-            </a:r>
-            <a:r>
-              <a:rPr lang="ja-JP" altLang="ja-JP">
-                <a:latin typeface="小塚明朝 Pro L"/>
-                <a:ea typeface="Meiryo UI" panose="020B0604030504040204" pitchFamily="34" charset="-128"/>
-                <a:cs typeface="ＭＳ Ｐゴシック" panose="020B0600070205080204" pitchFamily="34" charset="-128"/>
-              </a:rPr>
-              <a:t>イエスは十二人を任命し、彼らを使徒と呼ばれた。それは、彼らをご自分のそばに置くため、また彼らを遣わして宣教をさせ、</a:t>
-            </a:r>
-          </a:p>
-          <a:p>
-            <a:pPr marL="152400" marR="152400"/>
-            <a:r>
-              <a:rPr lang="en-US" altLang="ja-JP" dirty="0">
-                <a:latin typeface="小塚明朝 Pro L"/>
-                <a:ea typeface="Meiryo UI" panose="020B0604030504040204" pitchFamily="34" charset="-128"/>
-                <a:cs typeface="ＭＳ Ｐゴシック" panose="020B0600070205080204" pitchFamily="34" charset="-128"/>
-              </a:rPr>
-              <a:t>Mark 3:15</a:t>
-            </a:r>
-            <a:r>
-              <a:rPr lang="en-US" altLang="ja-JP" dirty="0">
-                <a:latin typeface="小塚明朝 Pro L"/>
-                <a:ea typeface="Meiryo UI" panose="020B0604030504040204" pitchFamily="34" charset="-128"/>
-                <a:cs typeface="ＭＳ Ｐゴシック" panose="020B0600070205080204" pitchFamily="34" charset="-128"/>
-              </a:rPr>
-              <a:t xml:space="preserve">  </a:t>
-            </a:r>
-            <a:r>
-              <a:rPr lang="ja-JP" altLang="ja-JP">
-                <a:latin typeface="小塚明朝 Pro L"/>
-                <a:ea typeface="Meiryo UI" panose="020B0604030504040204" pitchFamily="34" charset="-128"/>
-                <a:cs typeface="ＭＳ Ｐゴシック" panose="020B0600070205080204" pitchFamily="34" charset="-128"/>
-              </a:rPr>
-              <a:t>彼らに悪霊を追い出す権威を持たせるためであった。</a:t>
+              <a:t>Mark 16:7</a:t>
+            </a:r>
+            <a:r>
+              <a:rPr lang="en-US" altLang="ja-JP" dirty="0">
+                <a:latin typeface="小塚明朝 Pro L"/>
+                <a:ea typeface="Meiryo UI" panose="020B0604030504040204" pitchFamily="34" charset="-128"/>
+                <a:cs typeface="ＭＳ Ｐゴシック" panose="020B0600070205080204" pitchFamily="34" charset="-128"/>
+              </a:rPr>
+              <a:t xml:space="preserve">  </a:t>
+            </a:r>
+            <a:r>
+              <a:rPr lang="ja-JP" altLang="ja-JP">
+                <a:latin typeface="小塚明朝 Pro L"/>
+                <a:ea typeface="Meiryo UI" panose="020B0604030504040204" pitchFamily="34" charset="-128"/>
+                <a:cs typeface="ＭＳ Ｐゴシック" panose="020B0600070205080204" pitchFamily="34" charset="-128"/>
+              </a:rPr>
+              <a:t>さあ行って、弟子たちとペテロに伝えなさい。『イエスは、あなたがたより先にガリラヤへ行かれます。前に言われたとおり、そこでお会いできます』と。」</a:t>
             </a:r>
           </a:p>
           <a:p>
@@ -2931,23 +2905,50 @@
                 <a:ea typeface="Meiryo UI" panose="020B0604030504040204" pitchFamily="34" charset="-128"/>
                 <a:cs typeface="ＭＳ Ｐゴシック" panose="020B0600070205080204" pitchFamily="34" charset="-128"/>
               </a:rPr>
-              <a:t>Mark 9:18</a:t>
-            </a:r>
-            <a:r>
-              <a:rPr lang="en-US" altLang="ja-JP" dirty="0">
-                <a:latin typeface="小塚明朝 Pro L"/>
-                <a:ea typeface="Meiryo UI" panose="020B0604030504040204" pitchFamily="34" charset="-128"/>
-                <a:cs typeface="ＭＳ Ｐゴシック" panose="020B0600070205080204" pitchFamily="34" charset="-128"/>
-              </a:rPr>
-              <a:t xml:space="preserve">  </a:t>
-            </a:r>
-            <a:r>
-              <a:rPr lang="ja-JP" altLang="ja-JP">
-                <a:latin typeface="小塚明朝 Pro L"/>
-                <a:ea typeface="Meiryo UI" panose="020B0604030504040204" pitchFamily="34" charset="-128"/>
-                <a:cs typeface="ＭＳ Ｐゴシック" panose="020B0600070205080204" pitchFamily="34" charset="-128"/>
-              </a:rPr>
-              <a:t>その霊が息子に取りつくと、ところかまわず倒します。息子は泡を吹き、歯ぎしりして、からだをこわばらせます。それであなたのお弟子たちに、霊を追い出してくださいとお願いしたのですが、できませんでした。」</a:t>
+              <a:t>Mark 3:14</a:t>
+            </a:r>
+            <a:r>
+              <a:rPr lang="en-US" altLang="ja-JP" dirty="0">
+                <a:latin typeface="小塚明朝 Pro L"/>
+                <a:ea typeface="Meiryo UI" panose="020B0604030504040204" pitchFamily="34" charset="-128"/>
+                <a:cs typeface="ＭＳ Ｐゴシック" panose="020B0600070205080204" pitchFamily="34" charset="-128"/>
+              </a:rPr>
+              <a:t xml:space="preserve">  </a:t>
+            </a:r>
+            <a:r>
+              <a:rPr lang="ja-JP" altLang="ja-JP">
+                <a:latin typeface="小塚明朝 Pro L"/>
+                <a:ea typeface="Meiryo UI" panose="020B0604030504040204" pitchFamily="34" charset="-128"/>
+                <a:cs typeface="ＭＳ Ｐゴシック" panose="020B0600070205080204" pitchFamily="34" charset="-128"/>
+              </a:rPr>
+              <a:t>イエスは十二人を任命し、彼らを使徒と呼ばれた。それは、彼らをご自分のそばに置くため、また彼らを遣わして宣教をさせ、</a:t>
+            </a:r>
+          </a:p>
+          <a:p>
+            <a:pPr marL="152400" marR="152400"/>
+            <a:r>
+              <a:rPr lang="en-US" altLang="ja-JP" dirty="0">
+                <a:latin typeface="小塚明朝 Pro L"/>
+                <a:ea typeface="Meiryo UI" panose="020B0604030504040204" pitchFamily="34" charset="-128"/>
+                <a:cs typeface="ＭＳ Ｐゴシック" panose="020B0600070205080204" pitchFamily="34" charset="-128"/>
+              </a:rPr>
+              <a:t>Mark 3:15</a:t>
+            </a:r>
+            <a:r>
+              <a:rPr lang="en-US" altLang="ja-JP" dirty="0">
+                <a:latin typeface="小塚明朝 Pro L"/>
+                <a:ea typeface="Meiryo UI" panose="020B0604030504040204" pitchFamily="34" charset="-128"/>
+                <a:cs typeface="ＭＳ Ｐゴシック" panose="020B0600070205080204" pitchFamily="34" charset="-128"/>
+              </a:rPr>
+              <a:t xml:space="preserve">  </a:t>
+            </a:r>
+            <a:r>
+              <a:rPr lang="ja-JP" altLang="ja-JP">
+                <a:latin typeface="小塚明朝 Pro L"/>
+                <a:ea typeface="Meiryo UI" panose="020B0604030504040204" pitchFamily="34" charset="-128"/>
+                <a:cs typeface="ＭＳ Ｐゴシック" panose="020B0600070205080204" pitchFamily="34" charset="-128"/>
+              </a:rPr>
+              <a:t>彼らに悪霊を追い出す権威を持たせるためであった。</a:t>
             </a:r>
           </a:p>
           <a:p>
@@ -3019,23 +3020,23 @@
                 <a:ea typeface="Meiryo UI" panose="020B0604030504040204" pitchFamily="34" charset="-128"/>
                 <a:cs typeface="ＭＳ Ｐゴシック" panose="020B0600070205080204" pitchFamily="34" charset="-128"/>
               </a:rPr>
-              <a:t>Mark 9:19</a:t>
-            </a:r>
-            <a:r>
-              <a:rPr lang="en-US" altLang="ja-JP" dirty="0">
-                <a:latin typeface="小塚明朝 Pro L"/>
-                <a:ea typeface="Meiryo UI" panose="020B0604030504040204" pitchFamily="34" charset="-128"/>
-                <a:cs typeface="ＭＳ Ｐゴシック" panose="020B0600070205080204" pitchFamily="34" charset="-128"/>
-              </a:rPr>
-              <a:t xml:space="preserve">  </a:t>
-            </a:r>
-            <a:r>
-              <a:rPr lang="ja-JP" altLang="ja-JP">
-                <a:latin typeface="小塚明朝 Pro L"/>
-                <a:ea typeface="Meiryo UI" panose="020B0604030504040204" pitchFamily="34" charset="-128"/>
-                <a:cs typeface="ＭＳ Ｐゴシック" panose="020B0600070205080204" pitchFamily="34" charset="-128"/>
-              </a:rPr>
-              <a:t>イエスは彼らに言われた。「ああ、不信仰な時代だ。いつまで、わたしはあなたがたと一緒にいなければならないのか。いつまで、あなたがたに我慢しなければならないのか。その子をわたしのところに連れて来なさい。」</a:t>
+              <a:t>Mark 9:18</a:t>
+            </a:r>
+            <a:r>
+              <a:rPr lang="en-US" altLang="ja-JP" dirty="0">
+                <a:latin typeface="小塚明朝 Pro L"/>
+                <a:ea typeface="Meiryo UI" panose="020B0604030504040204" pitchFamily="34" charset="-128"/>
+                <a:cs typeface="ＭＳ Ｐゴシック" panose="020B0600070205080204" pitchFamily="34" charset="-128"/>
+              </a:rPr>
+              <a:t xml:space="preserve">  </a:t>
+            </a:r>
+            <a:r>
+              <a:rPr lang="ja-JP" altLang="ja-JP">
+                <a:latin typeface="小塚明朝 Pro L"/>
+                <a:ea typeface="Meiryo UI" panose="020B0604030504040204" pitchFamily="34" charset="-128"/>
+                <a:cs typeface="ＭＳ Ｐゴシック" panose="020B0600070205080204" pitchFamily="34" charset="-128"/>
+              </a:rPr>
+              <a:t>その霊が息子に取りつくと、ところかまわず倒します。息子は泡を吹き、歯ぎしりして、からだをこわばらせます。それであなたのお弟子たちに、霊を追い出してくださいとお願いしたのですが、できませんでした。」</a:t>
             </a:r>
           </a:p>
           <a:p>
@@ -3195,50 +3196,23 @@
                 <a:ea typeface="Meiryo UI" panose="020B0604030504040204" pitchFamily="34" charset="-128"/>
                 <a:cs typeface="ＭＳ Ｐゴシック" panose="020B0600070205080204" pitchFamily="34" charset="-128"/>
               </a:rPr>
-              <a:t>Mark 10:26</a:t>
-            </a:r>
-            <a:r>
-              <a:rPr lang="en-US" altLang="ja-JP" dirty="0">
-                <a:latin typeface="小塚明朝 Pro L"/>
-                <a:ea typeface="Meiryo UI" panose="020B0604030504040204" pitchFamily="34" charset="-128"/>
-                <a:cs typeface="ＭＳ Ｐゴシック" panose="020B0600070205080204" pitchFamily="34" charset="-128"/>
-              </a:rPr>
-              <a:t xml:space="preserve">  </a:t>
-            </a:r>
-            <a:r>
-              <a:rPr lang="ja-JP" altLang="ja-JP">
-                <a:latin typeface="小塚明朝 Pro L"/>
-                <a:ea typeface="Meiryo UI" panose="020B0604030504040204" pitchFamily="34" charset="-128"/>
-                <a:cs typeface="ＭＳ Ｐゴシック" panose="020B0600070205080204" pitchFamily="34" charset="-128"/>
-              </a:rPr>
-              <a:t>弟子たちは、ますます驚いて互いに言った。「それでは、だれが救われることができるでしょう。」</a:t>
-            </a:r>
-          </a:p>
-          <a:p>
-            <a:pPr marL="152400" marR="152400"/>
-            <a:r>
-              <a:rPr lang="en-US" altLang="ja-JP" dirty="0">
-                <a:latin typeface="小塚明朝 Pro L"/>
-                <a:ea typeface="Meiryo UI" panose="020B0604030504040204" pitchFamily="34" charset="-128"/>
-                <a:cs typeface="ＭＳ Ｐゴシック" panose="020B0600070205080204" pitchFamily="34" charset="-128"/>
-              </a:rPr>
-              <a:t>Mark 10:27</a:t>
-            </a:r>
-            <a:r>
-              <a:rPr lang="en-US" altLang="ja-JP" dirty="0">
-                <a:latin typeface="小塚明朝 Pro L"/>
-                <a:ea typeface="Meiryo UI" panose="020B0604030504040204" pitchFamily="34" charset="-128"/>
-                <a:cs typeface="ＭＳ Ｐゴシック" panose="020B0600070205080204" pitchFamily="34" charset="-128"/>
-              </a:rPr>
-              <a:t xml:space="preserve">  </a:t>
-            </a:r>
-            <a:r>
-              <a:rPr lang="ja-JP" altLang="ja-JP">
-                <a:latin typeface="小塚明朝 Pro L"/>
-                <a:ea typeface="Meiryo UI" panose="020B0604030504040204" pitchFamily="34" charset="-128"/>
-                <a:cs typeface="ＭＳ Ｐゴシック" panose="020B0600070205080204" pitchFamily="34" charset="-128"/>
-              </a:rPr>
-              <a:t>イエスは彼らをじっと見て言われた。「それは人にはできないことです。しかし、神は違います。神にはどんなことでもできるのです。」</a:t>
+              <a:t>Mark 9:19</a:t>
+            </a:r>
+            <a:r>
+              <a:rPr lang="en-US" altLang="ja-JP" dirty="0">
+                <a:latin typeface="小塚明朝 Pro L"/>
+                <a:ea typeface="Meiryo UI" panose="020B0604030504040204" pitchFamily="34" charset="-128"/>
+                <a:cs typeface="ＭＳ Ｐゴシック" panose="020B0600070205080204" pitchFamily="34" charset="-128"/>
+              </a:rPr>
+              <a:t xml:space="preserve">  </a:t>
+            </a:r>
+            <a:r>
+              <a:rPr lang="ja-JP" altLang="ja-JP">
+                <a:latin typeface="小塚明朝 Pro L"/>
+                <a:ea typeface="Meiryo UI" panose="020B0604030504040204" pitchFamily="34" charset="-128"/>
+                <a:cs typeface="ＭＳ Ｐゴシック" panose="020B0600070205080204" pitchFamily="34" charset="-128"/>
+              </a:rPr>
+              <a:t>イエスは彼らに言われた。「ああ、不信仰な時代だ。いつまで、わたしはあなたがたと一緒にいなければならないのか。いつまで、あなたがたに我慢しなければならないのか。その子をわたしのところに連れて来なさい。」</a:t>
             </a:r>
           </a:p>
           <a:p>
@@ -3260,6 +3234,121 @@
 </file>
 
 <file path=ppt/slides/slide31.xml><?xml version="1.0" encoding="utf-8"?>
+<p:sld xmlns:a="http://schemas.openxmlformats.org/drawingml/2006/main" xmlns:r="http://schemas.openxmlformats.org/officeDocument/2006/relationships" xmlns:p="http://schemas.openxmlformats.org/presentationml/2006/main">
+  <p:cSld>
+    <p:spTree>
+      <p:nvGrpSpPr>
+        <p:cNvPr id="1" name="">
+          <a:extLst>
+            <a:ext uri="{FF2B5EF4-FFF2-40B4-BE49-F238E27FC236}">
+              <a16:creationId xmlns:a16="http://schemas.microsoft.com/office/drawing/2014/main" id="{D9704123-7415-9F33-DD50-7C6B95E5C492}"/>
+            </a:ext>
+          </a:extLst>
+        </p:cNvPr>
+        <p:cNvGrpSpPr/>
+        <p:nvPr/>
+      </p:nvGrpSpPr>
+      <p:grpSpPr>
+        <a:xfrm>
+          <a:off x="0" y="0"/>
+          <a:ext cx="0" cy="0"/>
+          <a:chOff x="0" y="0"/>
+          <a:chExt cx="0" cy="0"/>
+        </a:xfrm>
+      </p:grpSpPr>
+      <p:sp>
+        <p:nvSpPr>
+          <p:cNvPr id="3" name="テキスト プレースホルダー 2">
+            <a:extLst>
+              <a:ext uri="{FF2B5EF4-FFF2-40B4-BE49-F238E27FC236}">
+                <a16:creationId xmlns:a16="http://schemas.microsoft.com/office/drawing/2014/main" id="{1880A210-FE0B-5881-C4EC-9785B3BA9525}"/>
+              </a:ext>
+            </a:extLst>
+          </p:cNvPr>
+          <p:cNvSpPr>
+            <a:spLocks noGrp="1"/>
+          </p:cNvSpPr>
+          <p:nvPr>
+            <p:ph type="body" sz="quarter" idx="10"/>
+          </p:nvPr>
+        </p:nvSpPr>
+        <p:spPr/>
+        <p:txBody>
+          <a:bodyPr/>
+          <a:lstStyle/>
+          <a:p>
+            <a:pPr marL="152400" marR="152400"/>
+            <a:r>
+              <a:rPr lang="en-US" altLang="ja-JP" dirty="0">
+                <a:latin typeface="小塚明朝 Pro L"/>
+                <a:ea typeface="Meiryo UI" panose="020B0604030504040204" pitchFamily="34" charset="-128"/>
+                <a:cs typeface="ＭＳ Ｐゴシック" panose="020B0600070205080204" pitchFamily="34" charset="-128"/>
+              </a:rPr>
+              <a:t>Mark 10:26</a:t>
+            </a:r>
+            <a:r>
+              <a:rPr lang="en-US" altLang="ja-JP" dirty="0">
+                <a:latin typeface="小塚明朝 Pro L"/>
+                <a:ea typeface="Meiryo UI" panose="020B0604030504040204" pitchFamily="34" charset="-128"/>
+                <a:cs typeface="ＭＳ Ｐゴシック" panose="020B0600070205080204" pitchFamily="34" charset="-128"/>
+              </a:rPr>
+              <a:t xml:space="preserve">  </a:t>
+            </a:r>
+            <a:r>
+              <a:rPr lang="ja-JP" altLang="ja-JP">
+                <a:latin typeface="小塚明朝 Pro L"/>
+                <a:ea typeface="Meiryo UI" panose="020B0604030504040204" pitchFamily="34" charset="-128"/>
+                <a:cs typeface="ＭＳ Ｐゴシック" panose="020B0600070205080204" pitchFamily="34" charset="-128"/>
+              </a:rPr>
+              <a:t>弟子たちは、ますます驚いて互いに言った。「それでは、だれが救われることができるでしょう。」</a:t>
+            </a:r>
+          </a:p>
+          <a:p>
+            <a:pPr marL="152400" marR="152400"/>
+            <a:r>
+              <a:rPr lang="en-US" altLang="ja-JP" dirty="0">
+                <a:latin typeface="小塚明朝 Pro L"/>
+                <a:ea typeface="Meiryo UI" panose="020B0604030504040204" pitchFamily="34" charset="-128"/>
+                <a:cs typeface="ＭＳ Ｐゴシック" panose="020B0600070205080204" pitchFamily="34" charset="-128"/>
+              </a:rPr>
+              <a:t>Mark 10:27</a:t>
+            </a:r>
+            <a:r>
+              <a:rPr lang="en-US" altLang="ja-JP" dirty="0">
+                <a:latin typeface="小塚明朝 Pro L"/>
+                <a:ea typeface="Meiryo UI" panose="020B0604030504040204" pitchFamily="34" charset="-128"/>
+                <a:cs typeface="ＭＳ Ｐゴシック" panose="020B0600070205080204" pitchFamily="34" charset="-128"/>
+              </a:rPr>
+              <a:t xml:space="preserve">  </a:t>
+            </a:r>
+            <a:r>
+              <a:rPr lang="ja-JP" altLang="ja-JP">
+                <a:latin typeface="小塚明朝 Pro L"/>
+                <a:ea typeface="Meiryo UI" panose="020B0604030504040204" pitchFamily="34" charset="-128"/>
+                <a:cs typeface="ＭＳ Ｐゴシック" panose="020B0600070205080204" pitchFamily="34" charset="-128"/>
+              </a:rPr>
+              <a:t>イエスは彼らをじっと見て言われた。「それは人にはできないことです。しかし、神は違います。神にはどんなことでもできるのです。」</a:t>
+            </a:r>
+          </a:p>
+          <a:p>
+            <a:endParaRPr kumimoji="1" lang="ja-JP" altLang="en-US"/>
+          </a:p>
+        </p:txBody>
+      </p:sp>
+    </p:spTree>
+    <p:extLst>
+      <p:ext uri="{BB962C8B-B14F-4D97-AF65-F5344CB8AC3E}">
+        <p14:creationId xmlns:p14="http://schemas.microsoft.com/office/powerpoint/2010/main" val="2834000026"/>
+      </p:ext>
+    </p:extLst>
+  </p:cSld>
+  <p:clrMapOvr>
+    <a:masterClrMapping/>
+  </p:clrMapOvr>
+</p:sld>
+</file>
+
+<file path=ppt/slides/slide32.xml><?xml version="1.0" encoding="utf-8"?>
 <p:sld xmlns:a="http://schemas.openxmlformats.org/drawingml/2006/main" xmlns:r="http://schemas.openxmlformats.org/officeDocument/2006/relationships" xmlns:p="http://schemas.openxmlformats.org/presentationml/2006/main">
   <p:cSld>
     <p:spTree>

</xml_diff>